<commit_message>
Update PPT slide strings to exactly match requested nomenclature
</commit_message>
<xml_diff>
--- a/docs/Project_Presentation.pptx
+++ b/docs/Project_Presentation.pptx
@@ -5,45 +5,45 @@
     <p:sldMasterId id="2147483648" r:id="rId1"/>
   </p:sldMasterIdLst>
   <p:sldIdLst>
-    <p:sldId id="256" r:id="rId7"/>
-    <p:sldId id="257" r:id="rId8"/>
-    <p:sldId id="258" r:id="rId9"/>
-    <p:sldId id="259" r:id="rId10"/>
-    <p:sldId id="260" r:id="rId11"/>
-    <p:sldId id="261" r:id="rId12"/>
-    <p:sldId id="262" r:id="rId13"/>
-    <p:sldId id="263" r:id="rId14"/>
-    <p:sldId id="264" r:id="rId15"/>
-    <p:sldId id="265" r:id="rId16"/>
-    <p:sldId id="266" r:id="rId17"/>
-    <p:sldId id="267" r:id="rId18"/>
-    <p:sldId id="268" r:id="rId19"/>
-    <p:sldId id="269" r:id="rId20"/>
-    <p:sldId id="270" r:id="rId21"/>
-    <p:sldId id="271" r:id="rId22"/>
-    <p:sldId id="272" r:id="rId23"/>
-    <p:sldId id="273" r:id="rId24"/>
-    <p:sldId id="274" r:id="rId25"/>
-    <p:sldId id="275" r:id="rId26"/>
-    <p:sldId id="276" r:id="rId27"/>
-    <p:sldId id="277" r:id="rId28"/>
-    <p:sldId id="278" r:id="rId29"/>
-    <p:sldId id="279" r:id="rId30"/>
-    <p:sldId id="280" r:id="rId31"/>
-    <p:sldId id="281" r:id="rId32"/>
-    <p:sldId id="282" r:id="rId33"/>
-    <p:sldId id="283" r:id="rId34"/>
-    <p:sldId id="284" r:id="rId35"/>
-    <p:sldId id="285" r:id="rId36"/>
-    <p:sldId id="286" r:id="rId37"/>
-    <p:sldId id="287" r:id="rId38"/>
-    <p:sldId id="288" r:id="rId39"/>
-    <p:sldId id="289" r:id="rId40"/>
-    <p:sldId id="290" r:id="rId41"/>
-    <p:sldId id="291" r:id="rId42"/>
-    <p:sldId id="292" r:id="rId43"/>
-    <p:sldId id="293" r:id="rId44"/>
-    <p:sldId id="294" r:id="rId45"/>
+    <p:sldId id="256" r:id="rId2"/>
+    <p:sldId id="257" r:id="rId3"/>
+    <p:sldId id="258" r:id="rId4"/>
+    <p:sldId id="259" r:id="rId5"/>
+    <p:sldId id="260" r:id="rId6"/>
+    <p:sldId id="261" r:id="rId7"/>
+    <p:sldId id="262" r:id="rId8"/>
+    <p:sldId id="263" r:id="rId9"/>
+    <p:sldId id="264" r:id="rId10"/>
+    <p:sldId id="265" r:id="rId11"/>
+    <p:sldId id="266" r:id="rId12"/>
+    <p:sldId id="267" r:id="rId13"/>
+    <p:sldId id="268" r:id="rId14"/>
+    <p:sldId id="269" r:id="rId15"/>
+    <p:sldId id="270" r:id="rId16"/>
+    <p:sldId id="271" r:id="rId17"/>
+    <p:sldId id="272" r:id="rId18"/>
+    <p:sldId id="273" r:id="rId19"/>
+    <p:sldId id="274" r:id="rId20"/>
+    <p:sldId id="275" r:id="rId21"/>
+    <p:sldId id="276" r:id="rId22"/>
+    <p:sldId id="277" r:id="rId23"/>
+    <p:sldId id="278" r:id="rId24"/>
+    <p:sldId id="279" r:id="rId25"/>
+    <p:sldId id="280" r:id="rId26"/>
+    <p:sldId id="281" r:id="rId27"/>
+    <p:sldId id="282" r:id="rId28"/>
+    <p:sldId id="283" r:id="rId29"/>
+    <p:sldId id="284" r:id="rId30"/>
+    <p:sldId id="285" r:id="rId31"/>
+    <p:sldId id="286" r:id="rId32"/>
+    <p:sldId id="287" r:id="rId33"/>
+    <p:sldId id="288" r:id="rId34"/>
+    <p:sldId id="289" r:id="rId35"/>
+    <p:sldId id="290" r:id="rId36"/>
+    <p:sldId id="291" r:id="rId37"/>
+    <p:sldId id="292" r:id="rId38"/>
+    <p:sldId id="293" r:id="rId39"/>
+    <p:sldId id="294" r:id="rId40"/>
   </p:sldIdLst>
   <p:sldSz cx="9144000" cy="6858000" type="screen4x3"/>
   <p:notesSz cx="6858000" cy="9144000"/>
@@ -142,6 +142,22 @@
       </a:defRPr>
     </a:lvl9pPr>
   </p:defaultTextStyle>
+  <p:extLst>
+    <p:ext uri="{EFAFB233-063F-42B5-8137-9DF3F51BA10A}">
+      <p15:sldGuideLst xmlns:p15="http://schemas.microsoft.com/office/powerpoint/2012/main">
+        <p15:guide id="1" orient="horz" pos="2160">
+          <p15:clr>
+            <a:srgbClr val="A4A3A4"/>
+          </p15:clr>
+        </p15:guide>
+        <p15:guide id="2" pos="2880">
+          <p15:clr>
+            <a:srgbClr val="A4A3A4"/>
+          </p15:clr>
+        </p15:guide>
+      </p15:sldGuideLst>
+    </p:ext>
+  </p:extLst>
 </p:presentation>
 </file>
 
@@ -183,10 +199,9 @@
           <a:lstStyle/>
           <a:p>
             <a:r>
-              <a:rPr lang="en-US" smtClean="0"/>
+              <a:rPr lang="en-US"/>
               <a:t>Click to edit Master title style</a:t>
             </a:r>
-            <a:endParaRPr lang="en-US"/>
           </a:p>
         </p:txBody>
       </p:sp>
@@ -302,10 +317,9 @@
           </a:lstStyle>
           <a:p>
             <a:r>
-              <a:rPr lang="en-US" smtClean="0"/>
+              <a:rPr lang="en-US"/>
               <a:t>Click to edit Master subtitle style</a:t>
             </a:r>
-            <a:endParaRPr lang="en-US"/>
           </a:p>
         </p:txBody>
       </p:sp>
@@ -326,7 +340,7 @@
           <a:p>
             <a:fld id="{5BCAD085-E8A6-8845-BD4E-CB4CCA059FC4}" type="datetimeFigureOut">
               <a:rPr lang="en-US" smtClean="0"/>
-              <a:t>1/27/13</a:t>
+              <a:t>4/7/2026</a:t>
             </a:fld>
             <a:endParaRPr lang="en-US"/>
           </a:p>
@@ -420,10 +434,9 @@
           <a:lstStyle/>
           <a:p>
             <a:r>
-              <a:rPr lang="en-US" smtClean="0"/>
+              <a:rPr lang="en-US"/>
               <a:t>Click to edit Master title style</a:t>
             </a:r>
-            <a:endParaRPr lang="en-US"/>
           </a:p>
         </p:txBody>
       </p:sp>
@@ -444,38 +457,37 @@
           <a:p>
             <a:pPr lvl="0"/>
             <a:r>
-              <a:rPr lang="en-US" smtClean="0"/>
+              <a:rPr lang="en-US"/>
               <a:t>Click to edit Master text styles</a:t>
             </a:r>
           </a:p>
           <a:p>
             <a:pPr lvl="1"/>
             <a:r>
-              <a:rPr lang="en-US" smtClean="0"/>
+              <a:rPr lang="en-US"/>
               <a:t>Second level</a:t>
             </a:r>
           </a:p>
           <a:p>
             <a:pPr lvl="2"/>
             <a:r>
-              <a:rPr lang="en-US" smtClean="0"/>
+              <a:rPr lang="en-US"/>
               <a:t>Third level</a:t>
             </a:r>
           </a:p>
           <a:p>
             <a:pPr lvl="3"/>
             <a:r>
-              <a:rPr lang="en-US" smtClean="0"/>
+              <a:rPr lang="en-US"/>
               <a:t>Fourth level</a:t>
             </a:r>
           </a:p>
           <a:p>
             <a:pPr lvl="4"/>
             <a:r>
-              <a:rPr lang="en-US" smtClean="0"/>
+              <a:rPr lang="en-US"/>
               <a:t>Fifth level</a:t>
             </a:r>
-            <a:endParaRPr lang="en-US"/>
           </a:p>
         </p:txBody>
       </p:sp>
@@ -496,7 +508,7 @@
           <a:p>
             <a:fld id="{5BCAD085-E8A6-8845-BD4E-CB4CCA059FC4}" type="datetimeFigureOut">
               <a:rPr lang="en-US" smtClean="0"/>
-              <a:t>1/27/13</a:t>
+              <a:t>4/7/2026</a:t>
             </a:fld>
             <a:endParaRPr lang="en-US"/>
           </a:p>
@@ -595,10 +607,9 @@
           <a:lstStyle/>
           <a:p>
             <a:r>
-              <a:rPr lang="en-US" smtClean="0"/>
+              <a:rPr lang="en-US"/>
               <a:t>Click to edit Master title style</a:t>
             </a:r>
-            <a:endParaRPr lang="en-US"/>
           </a:p>
         </p:txBody>
       </p:sp>
@@ -624,38 +635,37 @@
           <a:p>
             <a:pPr lvl="0"/>
             <a:r>
-              <a:rPr lang="en-US" smtClean="0"/>
+              <a:rPr lang="en-US"/>
               <a:t>Click to edit Master text styles</a:t>
             </a:r>
           </a:p>
           <a:p>
             <a:pPr lvl="1"/>
             <a:r>
-              <a:rPr lang="en-US" smtClean="0"/>
+              <a:rPr lang="en-US"/>
               <a:t>Second level</a:t>
             </a:r>
           </a:p>
           <a:p>
             <a:pPr lvl="2"/>
             <a:r>
-              <a:rPr lang="en-US" smtClean="0"/>
+              <a:rPr lang="en-US"/>
               <a:t>Third level</a:t>
             </a:r>
           </a:p>
           <a:p>
             <a:pPr lvl="3"/>
             <a:r>
-              <a:rPr lang="en-US" smtClean="0"/>
+              <a:rPr lang="en-US"/>
               <a:t>Fourth level</a:t>
             </a:r>
           </a:p>
           <a:p>
             <a:pPr lvl="4"/>
             <a:r>
-              <a:rPr lang="en-US" smtClean="0"/>
+              <a:rPr lang="en-US"/>
               <a:t>Fifth level</a:t>
             </a:r>
-            <a:endParaRPr lang="en-US"/>
           </a:p>
         </p:txBody>
       </p:sp>
@@ -676,7 +686,7 @@
           <a:p>
             <a:fld id="{5BCAD085-E8A6-8845-BD4E-CB4CCA059FC4}" type="datetimeFigureOut">
               <a:rPr lang="en-US" smtClean="0"/>
-              <a:t>1/27/13</a:t>
+              <a:t>4/7/2026</a:t>
             </a:fld>
             <a:endParaRPr lang="en-US"/>
           </a:p>
@@ -770,10 +780,9 @@
           <a:lstStyle/>
           <a:p>
             <a:r>
-              <a:rPr lang="en-US" smtClean="0"/>
+              <a:rPr lang="en-US"/>
               <a:t>Click to edit Master title style</a:t>
             </a:r>
-            <a:endParaRPr lang="en-US"/>
           </a:p>
         </p:txBody>
       </p:sp>
@@ -794,38 +803,37 @@
           <a:p>
             <a:pPr lvl="0"/>
             <a:r>
-              <a:rPr lang="en-US" smtClean="0"/>
+              <a:rPr lang="en-US"/>
               <a:t>Click to edit Master text styles</a:t>
             </a:r>
           </a:p>
           <a:p>
             <a:pPr lvl="1"/>
             <a:r>
-              <a:rPr lang="en-US" smtClean="0"/>
+              <a:rPr lang="en-US"/>
               <a:t>Second level</a:t>
             </a:r>
           </a:p>
           <a:p>
             <a:pPr lvl="2"/>
             <a:r>
-              <a:rPr lang="en-US" smtClean="0"/>
+              <a:rPr lang="en-US"/>
               <a:t>Third level</a:t>
             </a:r>
           </a:p>
           <a:p>
             <a:pPr lvl="3"/>
             <a:r>
-              <a:rPr lang="en-US" smtClean="0"/>
+              <a:rPr lang="en-US"/>
               <a:t>Fourth level</a:t>
             </a:r>
           </a:p>
           <a:p>
             <a:pPr lvl="4"/>
             <a:r>
-              <a:rPr lang="en-US" smtClean="0"/>
+              <a:rPr lang="en-US"/>
               <a:t>Fifth level</a:t>
             </a:r>
-            <a:endParaRPr lang="en-US"/>
           </a:p>
         </p:txBody>
       </p:sp>
@@ -846,7 +854,7 @@
           <a:p>
             <a:fld id="{5BCAD085-E8A6-8845-BD4E-CB4CCA059FC4}" type="datetimeFigureOut">
               <a:rPr lang="en-US" smtClean="0"/>
-              <a:t>1/27/13</a:t>
+              <a:t>4/7/2026</a:t>
             </a:fld>
             <a:endParaRPr lang="en-US"/>
           </a:p>
@@ -949,10 +957,9 @@
           </a:lstStyle>
           <a:p>
             <a:r>
-              <a:rPr lang="en-US" smtClean="0"/>
+              <a:rPr lang="en-US"/>
               <a:t>Click to edit Master title style</a:t>
             </a:r>
-            <a:endParaRPr lang="en-US"/>
           </a:p>
         </p:txBody>
       </p:sp>
@@ -1069,7 +1076,7 @@
           <a:p>
             <a:pPr lvl="0"/>
             <a:r>
-              <a:rPr lang="en-US" smtClean="0"/>
+              <a:rPr lang="en-US"/>
               <a:t>Click to edit Master text styles</a:t>
             </a:r>
           </a:p>
@@ -1092,7 +1099,7 @@
           <a:p>
             <a:fld id="{5BCAD085-E8A6-8845-BD4E-CB4CCA059FC4}" type="datetimeFigureOut">
               <a:rPr lang="en-US" smtClean="0"/>
-              <a:t>1/27/13</a:t>
+              <a:t>4/7/2026</a:t>
             </a:fld>
             <a:endParaRPr lang="en-US"/>
           </a:p>
@@ -1186,10 +1193,9 @@
           <a:lstStyle/>
           <a:p>
             <a:r>
-              <a:rPr lang="en-US" smtClean="0"/>
+              <a:rPr lang="en-US"/>
               <a:t>Click to edit Master title style</a:t>
             </a:r>
-            <a:endParaRPr lang="en-US"/>
           </a:p>
         </p:txBody>
       </p:sp>
@@ -1243,38 +1249,37 @@
           <a:p>
             <a:pPr lvl="0"/>
             <a:r>
-              <a:rPr lang="en-US" smtClean="0"/>
+              <a:rPr lang="en-US"/>
               <a:t>Click to edit Master text styles</a:t>
             </a:r>
           </a:p>
           <a:p>
             <a:pPr lvl="1"/>
             <a:r>
-              <a:rPr lang="en-US" smtClean="0"/>
+              <a:rPr lang="en-US"/>
               <a:t>Second level</a:t>
             </a:r>
           </a:p>
           <a:p>
             <a:pPr lvl="2"/>
             <a:r>
-              <a:rPr lang="en-US" smtClean="0"/>
+              <a:rPr lang="en-US"/>
               <a:t>Third level</a:t>
             </a:r>
           </a:p>
           <a:p>
             <a:pPr lvl="3"/>
             <a:r>
-              <a:rPr lang="en-US" smtClean="0"/>
+              <a:rPr lang="en-US"/>
               <a:t>Fourth level</a:t>
             </a:r>
           </a:p>
           <a:p>
             <a:pPr lvl="4"/>
             <a:r>
-              <a:rPr lang="en-US" smtClean="0"/>
+              <a:rPr lang="en-US"/>
               <a:t>Fifth level</a:t>
             </a:r>
-            <a:endParaRPr lang="en-US"/>
           </a:p>
         </p:txBody>
       </p:sp>
@@ -1328,38 +1333,37 @@
           <a:p>
             <a:pPr lvl="0"/>
             <a:r>
-              <a:rPr lang="en-US" smtClean="0"/>
+              <a:rPr lang="en-US"/>
               <a:t>Click to edit Master text styles</a:t>
             </a:r>
           </a:p>
           <a:p>
             <a:pPr lvl="1"/>
             <a:r>
-              <a:rPr lang="en-US" smtClean="0"/>
+              <a:rPr lang="en-US"/>
               <a:t>Second level</a:t>
             </a:r>
           </a:p>
           <a:p>
             <a:pPr lvl="2"/>
             <a:r>
-              <a:rPr lang="en-US" smtClean="0"/>
+              <a:rPr lang="en-US"/>
               <a:t>Third level</a:t>
             </a:r>
           </a:p>
           <a:p>
             <a:pPr lvl="3"/>
             <a:r>
-              <a:rPr lang="en-US" smtClean="0"/>
+              <a:rPr lang="en-US"/>
               <a:t>Fourth level</a:t>
             </a:r>
           </a:p>
           <a:p>
             <a:pPr lvl="4"/>
             <a:r>
-              <a:rPr lang="en-US" smtClean="0"/>
+              <a:rPr lang="en-US"/>
               <a:t>Fifth level</a:t>
             </a:r>
-            <a:endParaRPr lang="en-US"/>
           </a:p>
         </p:txBody>
       </p:sp>
@@ -1380,7 +1384,7 @@
           <a:p>
             <a:fld id="{5BCAD085-E8A6-8845-BD4E-CB4CCA059FC4}" type="datetimeFigureOut">
               <a:rPr lang="en-US" smtClean="0"/>
-              <a:t>1/27/13</a:t>
+              <a:t>4/7/2026</a:t>
             </a:fld>
             <a:endParaRPr lang="en-US"/>
           </a:p>
@@ -1478,10 +1482,9 @@
           </a:lstStyle>
           <a:p>
             <a:r>
-              <a:rPr lang="en-US" smtClean="0"/>
+              <a:rPr lang="en-US"/>
               <a:t>Click to edit Master title style</a:t>
             </a:r>
-            <a:endParaRPr lang="en-US"/>
           </a:p>
         </p:txBody>
       </p:sp>
@@ -1544,7 +1547,7 @@
           <a:p>
             <a:pPr lvl="0"/>
             <a:r>
-              <a:rPr lang="en-US" smtClean="0"/>
+              <a:rPr lang="en-US"/>
               <a:t>Click to edit Master text styles</a:t>
             </a:r>
           </a:p>
@@ -1600,38 +1603,37 @@
           <a:p>
             <a:pPr lvl="0"/>
             <a:r>
-              <a:rPr lang="en-US" smtClean="0"/>
+              <a:rPr lang="en-US"/>
               <a:t>Click to edit Master text styles</a:t>
             </a:r>
           </a:p>
           <a:p>
             <a:pPr lvl="1"/>
             <a:r>
-              <a:rPr lang="en-US" smtClean="0"/>
+              <a:rPr lang="en-US"/>
               <a:t>Second level</a:t>
             </a:r>
           </a:p>
           <a:p>
             <a:pPr lvl="2"/>
             <a:r>
-              <a:rPr lang="en-US" smtClean="0"/>
+              <a:rPr lang="en-US"/>
               <a:t>Third level</a:t>
             </a:r>
           </a:p>
           <a:p>
             <a:pPr lvl="3"/>
             <a:r>
-              <a:rPr lang="en-US" smtClean="0"/>
+              <a:rPr lang="en-US"/>
               <a:t>Fourth level</a:t>
             </a:r>
           </a:p>
           <a:p>
             <a:pPr lvl="4"/>
             <a:r>
-              <a:rPr lang="en-US" smtClean="0"/>
+              <a:rPr lang="en-US"/>
               <a:t>Fifth level</a:t>
             </a:r>
-            <a:endParaRPr lang="en-US"/>
           </a:p>
         </p:txBody>
       </p:sp>
@@ -1694,7 +1696,7 @@
           <a:p>
             <a:pPr lvl="0"/>
             <a:r>
-              <a:rPr lang="en-US" smtClean="0"/>
+              <a:rPr lang="en-US"/>
               <a:t>Click to edit Master text styles</a:t>
             </a:r>
           </a:p>
@@ -1750,38 +1752,37 @@
           <a:p>
             <a:pPr lvl="0"/>
             <a:r>
-              <a:rPr lang="en-US" smtClean="0"/>
+              <a:rPr lang="en-US"/>
               <a:t>Click to edit Master text styles</a:t>
             </a:r>
           </a:p>
           <a:p>
             <a:pPr lvl="1"/>
             <a:r>
-              <a:rPr lang="en-US" smtClean="0"/>
+              <a:rPr lang="en-US"/>
               <a:t>Second level</a:t>
             </a:r>
           </a:p>
           <a:p>
             <a:pPr lvl="2"/>
             <a:r>
-              <a:rPr lang="en-US" smtClean="0"/>
+              <a:rPr lang="en-US"/>
               <a:t>Third level</a:t>
             </a:r>
           </a:p>
           <a:p>
             <a:pPr lvl="3"/>
             <a:r>
-              <a:rPr lang="en-US" smtClean="0"/>
+              <a:rPr lang="en-US"/>
               <a:t>Fourth level</a:t>
             </a:r>
           </a:p>
           <a:p>
             <a:pPr lvl="4"/>
             <a:r>
-              <a:rPr lang="en-US" smtClean="0"/>
+              <a:rPr lang="en-US"/>
               <a:t>Fifth level</a:t>
             </a:r>
-            <a:endParaRPr lang="en-US"/>
           </a:p>
         </p:txBody>
       </p:sp>
@@ -1802,7 +1803,7 @@
           <a:p>
             <a:fld id="{5BCAD085-E8A6-8845-BD4E-CB4CCA059FC4}" type="datetimeFigureOut">
               <a:rPr lang="en-US" smtClean="0"/>
-              <a:t>1/27/13</a:t>
+              <a:t>4/7/2026</a:t>
             </a:fld>
             <a:endParaRPr lang="en-US"/>
           </a:p>
@@ -1896,10 +1897,9 @@
           <a:lstStyle/>
           <a:p>
             <a:r>
-              <a:rPr lang="en-US" smtClean="0"/>
+              <a:rPr lang="en-US"/>
               <a:t>Click to edit Master title style</a:t>
             </a:r>
-            <a:endParaRPr lang="en-US"/>
           </a:p>
         </p:txBody>
       </p:sp>
@@ -1920,7 +1920,7 @@
           <a:p>
             <a:fld id="{5BCAD085-E8A6-8845-BD4E-CB4CCA059FC4}" type="datetimeFigureOut">
               <a:rPr lang="en-US" smtClean="0"/>
-              <a:t>1/27/13</a:t>
+              <a:t>4/7/2026</a:t>
             </a:fld>
             <a:endParaRPr lang="en-US"/>
           </a:p>
@@ -2015,7 +2015,7 @@
           <a:p>
             <a:fld id="{5BCAD085-E8A6-8845-BD4E-CB4CCA059FC4}" type="datetimeFigureOut">
               <a:rPr lang="en-US" smtClean="0"/>
-              <a:t>1/27/13</a:t>
+              <a:t>4/7/2026</a:t>
             </a:fld>
             <a:endParaRPr lang="en-US"/>
           </a:p>
@@ -2118,10 +2118,9 @@
           </a:lstStyle>
           <a:p>
             <a:r>
-              <a:rPr lang="en-US" smtClean="0"/>
+              <a:rPr lang="en-US"/>
               <a:t>Click to edit Master title style</a:t>
             </a:r>
-            <a:endParaRPr lang="en-US"/>
           </a:p>
         </p:txBody>
       </p:sp>
@@ -2175,38 +2174,37 @@
           <a:p>
             <a:pPr lvl="0"/>
             <a:r>
-              <a:rPr lang="en-US" smtClean="0"/>
+              <a:rPr lang="en-US"/>
               <a:t>Click to edit Master text styles</a:t>
             </a:r>
           </a:p>
           <a:p>
             <a:pPr lvl="1"/>
             <a:r>
-              <a:rPr lang="en-US" smtClean="0"/>
+              <a:rPr lang="en-US"/>
               <a:t>Second level</a:t>
             </a:r>
           </a:p>
           <a:p>
             <a:pPr lvl="2"/>
             <a:r>
-              <a:rPr lang="en-US" smtClean="0"/>
+              <a:rPr lang="en-US"/>
               <a:t>Third level</a:t>
             </a:r>
           </a:p>
           <a:p>
             <a:pPr lvl="3"/>
             <a:r>
-              <a:rPr lang="en-US" smtClean="0"/>
+              <a:rPr lang="en-US"/>
               <a:t>Fourth level</a:t>
             </a:r>
           </a:p>
           <a:p>
             <a:pPr lvl="4"/>
             <a:r>
-              <a:rPr lang="en-US" smtClean="0"/>
+              <a:rPr lang="en-US"/>
               <a:t>Fifth level</a:t>
             </a:r>
-            <a:endParaRPr lang="en-US"/>
           </a:p>
         </p:txBody>
       </p:sp>
@@ -2269,7 +2267,7 @@
           <a:p>
             <a:pPr lvl="0"/>
             <a:r>
-              <a:rPr lang="en-US" smtClean="0"/>
+              <a:rPr lang="en-US"/>
               <a:t>Click to edit Master text styles</a:t>
             </a:r>
           </a:p>
@@ -2292,7 +2290,7 @@
           <a:p>
             <a:fld id="{5BCAD085-E8A6-8845-BD4E-CB4CCA059FC4}" type="datetimeFigureOut">
               <a:rPr lang="en-US" smtClean="0"/>
-              <a:t>1/27/13</a:t>
+              <a:t>4/7/2026</a:t>
             </a:fld>
             <a:endParaRPr lang="en-US"/>
           </a:p>
@@ -2395,10 +2393,9 @@
           </a:lstStyle>
           <a:p>
             <a:r>
-              <a:rPr lang="en-US" smtClean="0"/>
+              <a:rPr lang="en-US"/>
               <a:t>Click to edit Master title style</a:t>
             </a:r>
-            <a:endParaRPr lang="en-US"/>
           </a:p>
         </p:txBody>
       </p:sp>
@@ -2522,7 +2519,7 @@
           <a:p>
             <a:pPr lvl="0"/>
             <a:r>
-              <a:rPr lang="en-US" smtClean="0"/>
+              <a:rPr lang="en-US"/>
               <a:t>Click to edit Master text styles</a:t>
             </a:r>
           </a:p>
@@ -2545,7 +2542,7 @@
           <a:p>
             <a:fld id="{5BCAD085-E8A6-8845-BD4E-CB4CCA059FC4}" type="datetimeFigureOut">
               <a:rPr lang="en-US" smtClean="0"/>
-              <a:t>1/27/13</a:t>
+              <a:t>4/7/2026</a:t>
             </a:fld>
             <a:endParaRPr lang="en-US"/>
           </a:p>
@@ -2654,10 +2651,9 @@
           <a:lstStyle/>
           <a:p>
             <a:r>
-              <a:rPr lang="en-US" smtClean="0"/>
+              <a:rPr lang="en-US"/>
               <a:t>Click to edit Master title style</a:t>
             </a:r>
-            <a:endParaRPr lang="en-US"/>
           </a:p>
         </p:txBody>
       </p:sp>
@@ -2688,38 +2684,37 @@
           <a:p>
             <a:pPr lvl="0"/>
             <a:r>
-              <a:rPr lang="en-US" smtClean="0"/>
+              <a:rPr lang="en-US"/>
               <a:t>Click to edit Master text styles</a:t>
             </a:r>
           </a:p>
           <a:p>
             <a:pPr lvl="1"/>
             <a:r>
-              <a:rPr lang="en-US" smtClean="0"/>
+              <a:rPr lang="en-US"/>
               <a:t>Second level</a:t>
             </a:r>
           </a:p>
           <a:p>
             <a:pPr lvl="2"/>
             <a:r>
-              <a:rPr lang="en-US" smtClean="0"/>
+              <a:rPr lang="en-US"/>
               <a:t>Third level</a:t>
             </a:r>
           </a:p>
           <a:p>
             <a:pPr lvl="3"/>
             <a:r>
-              <a:rPr lang="en-US" smtClean="0"/>
+              <a:rPr lang="en-US"/>
               <a:t>Fourth level</a:t>
             </a:r>
           </a:p>
           <a:p>
             <a:pPr lvl="4"/>
             <a:r>
-              <a:rPr lang="en-US" smtClean="0"/>
+              <a:rPr lang="en-US"/>
               <a:t>Fifth level</a:t>
             </a:r>
-            <a:endParaRPr lang="en-US"/>
           </a:p>
         </p:txBody>
       </p:sp>
@@ -2758,7 +2753,7 @@
           <a:p>
             <a:fld id="{5BCAD085-E8A6-8845-BD4E-CB4CCA059FC4}" type="datetimeFigureOut">
               <a:rPr lang="en-US" smtClean="0"/>
-              <a:t>1/27/13</a:t>
+              <a:t>4/7/2026</a:t>
             </a:fld>
             <a:endParaRPr lang="en-US"/>
           </a:p>
@@ -3117,7 +3112,7 @@
 </file>
 
 <file path=ppt/slides/slide1.xml><?xml version="1.0" encoding="utf-8"?>
-<p:sld xmlns:a="http://schemas.openxmlformats.org/drawingml/2006/main" xmlns:p="http://schemas.openxmlformats.org/presentationml/2006/main" xmlns:r="http://schemas.openxmlformats.org/officeDocument/2006/relationships">
+<p:sld xmlns:a="http://schemas.openxmlformats.org/drawingml/2006/main" xmlns:r="http://schemas.openxmlformats.org/officeDocument/2006/relationships" xmlns:p="http://schemas.openxmlformats.org/presentationml/2006/main">
   <p:cSld>
     <p:spTree>
       <p:nvGrpSpPr>
@@ -3125,7 +3120,14 @@
         <p:cNvGrpSpPr/>
         <p:nvPr/>
       </p:nvGrpSpPr>
-      <p:grpSpPr/>
+      <p:grpSpPr>
+        <a:xfrm>
+          <a:off x="0" y="0"/>
+          <a:ext cx="0" cy="0"/>
+          <a:chOff x="0" y="0"/>
+          <a:chExt cx="0" cy="0"/>
+        </a:xfrm>
+      </p:grpSpPr>
       <p:sp>
         <p:nvSpPr>
           <p:cNvPr id="2" name="Title 1"/>
@@ -3163,18 +3165,26 @@
           <a:lstStyle/>
           <a:p>
             <a:r>
+              <a:rPr dirty="0"/>
               <a:t>End-to-End Data Science Project</a:t>
             </a:r>
           </a:p>
           <a:p>
             <a:r>
+              <a:rPr dirty="0"/>
               <a:t>Name: Vishal Yadav</a:t>
             </a:r>
           </a:p>
           <a:p>
             <a:r>
-              <a:t>Register No: [Replace with your Register No]</a:t>
-            </a:r>
+              <a:rPr dirty="0"/>
+              <a:t>Register No:</a:t>
+            </a:r>
+            <a:r>
+              <a:rPr lang="en-US" dirty="0"/>
+              <a:t>24BCE1488</a:t>
+            </a:r>
+            <a:endParaRPr dirty="0"/>
           </a:p>
         </p:txBody>
       </p:sp>
@@ -3187,7 +3197,7 @@
 </file>
 
 <file path=ppt/slides/slide10.xml><?xml version="1.0" encoding="utf-8"?>
-<p:sld xmlns:a="http://schemas.openxmlformats.org/drawingml/2006/main" xmlns:p="http://schemas.openxmlformats.org/presentationml/2006/main" xmlns:r="http://schemas.openxmlformats.org/officeDocument/2006/relationships">
+<p:sld xmlns:a="http://schemas.openxmlformats.org/drawingml/2006/main" xmlns:r="http://schemas.openxmlformats.org/officeDocument/2006/relationships" xmlns:p="http://schemas.openxmlformats.org/presentationml/2006/main">
   <p:cSld>
     <p:spTree>
       <p:nvGrpSpPr>
@@ -3195,7 +3205,14 @@
         <p:cNvGrpSpPr/>
         <p:nvPr/>
       </p:nvGrpSpPr>
-      <p:grpSpPr/>
+      <p:grpSpPr>
+        <a:xfrm>
+          <a:off x="0" y="0"/>
+          <a:ext cx="0" cy="0"/>
+          <a:chOff x="0" y="0"/>
+          <a:chExt cx="0" cy="0"/>
+        </a:xfrm>
+      </p:grpSpPr>
       <p:sp>
         <p:nvSpPr>
           <p:cNvPr id="2" name="Title 1"/>
@@ -3336,7 +3353,7 @@
 </file>
 
 <file path=ppt/slides/slide11.xml><?xml version="1.0" encoding="utf-8"?>
-<p:sld xmlns:a="http://schemas.openxmlformats.org/drawingml/2006/main" xmlns:p="http://schemas.openxmlformats.org/presentationml/2006/main" xmlns:r="http://schemas.openxmlformats.org/officeDocument/2006/relationships">
+<p:sld xmlns:a="http://schemas.openxmlformats.org/drawingml/2006/main" xmlns:r="http://schemas.openxmlformats.org/officeDocument/2006/relationships" xmlns:p="http://schemas.openxmlformats.org/presentationml/2006/main">
   <p:cSld>
     <p:spTree>
       <p:nvGrpSpPr>
@@ -3344,7 +3361,14 @@
         <p:cNvGrpSpPr/>
         <p:nvPr/>
       </p:nvGrpSpPr>
-      <p:grpSpPr/>
+      <p:grpSpPr>
+        <a:xfrm>
+          <a:off x="0" y="0"/>
+          <a:ext cx="0" cy="0"/>
+          <a:chOff x="0" y="0"/>
+          <a:chExt cx="0" cy="0"/>
+        </a:xfrm>
+      </p:grpSpPr>
       <p:sp>
         <p:nvSpPr>
           <p:cNvPr id="2" name="Title 1"/>
@@ -3485,7 +3509,7 @@
 </file>
 
 <file path=ppt/slides/slide12.xml><?xml version="1.0" encoding="utf-8"?>
-<p:sld xmlns:a="http://schemas.openxmlformats.org/drawingml/2006/main" xmlns:p="http://schemas.openxmlformats.org/presentationml/2006/main" xmlns:r="http://schemas.openxmlformats.org/officeDocument/2006/relationships">
+<p:sld xmlns:a="http://schemas.openxmlformats.org/drawingml/2006/main" xmlns:r="http://schemas.openxmlformats.org/officeDocument/2006/relationships" xmlns:p="http://schemas.openxmlformats.org/presentationml/2006/main">
   <p:cSld>
     <p:spTree>
       <p:nvGrpSpPr>
@@ -3493,7 +3517,14 @@
         <p:cNvGrpSpPr/>
         <p:nvPr/>
       </p:nvGrpSpPr>
-      <p:grpSpPr/>
+      <p:grpSpPr>
+        <a:xfrm>
+          <a:off x="0" y="0"/>
+          <a:ext cx="0" cy="0"/>
+          <a:chOff x="0" y="0"/>
+          <a:chExt cx="0" cy="0"/>
+        </a:xfrm>
+      </p:grpSpPr>
       <p:sp>
         <p:nvSpPr>
           <p:cNvPr id="2" name="Title 1"/>
@@ -3579,7 +3610,7 @@
 </file>
 
 <file path=ppt/slides/slide13.xml><?xml version="1.0" encoding="utf-8"?>
-<p:sld xmlns:a="http://schemas.openxmlformats.org/drawingml/2006/main" xmlns:p="http://schemas.openxmlformats.org/presentationml/2006/main" xmlns:r="http://schemas.openxmlformats.org/officeDocument/2006/relationships">
+<p:sld xmlns:a="http://schemas.openxmlformats.org/drawingml/2006/main" xmlns:r="http://schemas.openxmlformats.org/officeDocument/2006/relationships" xmlns:p="http://schemas.openxmlformats.org/presentationml/2006/main">
   <p:cSld>
     <p:spTree>
       <p:nvGrpSpPr>
@@ -3587,7 +3618,14 @@
         <p:cNvGrpSpPr/>
         <p:nvPr/>
       </p:nvGrpSpPr>
-      <p:grpSpPr/>
+      <p:grpSpPr>
+        <a:xfrm>
+          <a:off x="0" y="0"/>
+          <a:ext cx="0" cy="0"/>
+          <a:chOff x="0" y="0"/>
+          <a:chExt cx="0" cy="0"/>
+        </a:xfrm>
+      </p:grpSpPr>
       <p:sp>
         <p:nvSpPr>
           <p:cNvPr id="2" name="Title 1"/>
@@ -3728,7 +3766,7 @@
 </file>
 
 <file path=ppt/slides/slide14.xml><?xml version="1.0" encoding="utf-8"?>
-<p:sld xmlns:a="http://schemas.openxmlformats.org/drawingml/2006/main" xmlns:p="http://schemas.openxmlformats.org/presentationml/2006/main" xmlns:r="http://schemas.openxmlformats.org/officeDocument/2006/relationships">
+<p:sld xmlns:a="http://schemas.openxmlformats.org/drawingml/2006/main" xmlns:r="http://schemas.openxmlformats.org/officeDocument/2006/relationships" xmlns:p="http://schemas.openxmlformats.org/presentationml/2006/main">
   <p:cSld>
     <p:spTree>
       <p:nvGrpSpPr>
@@ -3736,7 +3774,14 @@
         <p:cNvGrpSpPr/>
         <p:nvPr/>
       </p:nvGrpSpPr>
-      <p:grpSpPr/>
+      <p:grpSpPr>
+        <a:xfrm>
+          <a:off x="0" y="0"/>
+          <a:ext cx="0" cy="0"/>
+          <a:chOff x="0" y="0"/>
+          <a:chExt cx="0" cy="0"/>
+        </a:xfrm>
+      </p:grpSpPr>
       <p:sp>
         <p:nvSpPr>
           <p:cNvPr id="2" name="Title 1"/>
@@ -3877,7 +3922,7 @@
 </file>
 
 <file path=ppt/slides/slide15.xml><?xml version="1.0" encoding="utf-8"?>
-<p:sld xmlns:a="http://schemas.openxmlformats.org/drawingml/2006/main" xmlns:p="http://schemas.openxmlformats.org/presentationml/2006/main" xmlns:r="http://schemas.openxmlformats.org/officeDocument/2006/relationships">
+<p:sld xmlns:a="http://schemas.openxmlformats.org/drawingml/2006/main" xmlns:r="http://schemas.openxmlformats.org/officeDocument/2006/relationships" xmlns:p="http://schemas.openxmlformats.org/presentationml/2006/main">
   <p:cSld>
     <p:spTree>
       <p:nvGrpSpPr>
@@ -3885,7 +3930,14 @@
         <p:cNvGrpSpPr/>
         <p:nvPr/>
       </p:nvGrpSpPr>
-      <p:grpSpPr/>
+      <p:grpSpPr>
+        <a:xfrm>
+          <a:off x="0" y="0"/>
+          <a:ext cx="0" cy="0"/>
+          <a:chOff x="0" y="0"/>
+          <a:chExt cx="0" cy="0"/>
+        </a:xfrm>
+      </p:grpSpPr>
       <p:sp>
         <p:nvSpPr>
           <p:cNvPr id="2" name="Title 1"/>
@@ -4026,7 +4078,7 @@
 </file>
 
 <file path=ppt/slides/slide16.xml><?xml version="1.0" encoding="utf-8"?>
-<p:sld xmlns:a="http://schemas.openxmlformats.org/drawingml/2006/main" xmlns:p="http://schemas.openxmlformats.org/presentationml/2006/main" xmlns:r="http://schemas.openxmlformats.org/officeDocument/2006/relationships">
+<p:sld xmlns:a="http://schemas.openxmlformats.org/drawingml/2006/main" xmlns:r="http://schemas.openxmlformats.org/officeDocument/2006/relationships" xmlns:p="http://schemas.openxmlformats.org/presentationml/2006/main">
   <p:cSld>
     <p:spTree>
       <p:nvGrpSpPr>
@@ -4034,7 +4086,14 @@
         <p:cNvGrpSpPr/>
         <p:nvPr/>
       </p:nvGrpSpPr>
-      <p:grpSpPr/>
+      <p:grpSpPr>
+        <a:xfrm>
+          <a:off x="0" y="0"/>
+          <a:ext cx="0" cy="0"/>
+          <a:chOff x="0" y="0"/>
+          <a:chExt cx="0" cy="0"/>
+        </a:xfrm>
+      </p:grpSpPr>
       <p:sp>
         <p:nvSpPr>
           <p:cNvPr id="2" name="Title 1"/>
@@ -4175,7 +4234,7 @@
 </file>
 
 <file path=ppt/slides/slide17.xml><?xml version="1.0" encoding="utf-8"?>
-<p:sld xmlns:a="http://schemas.openxmlformats.org/drawingml/2006/main" xmlns:p="http://schemas.openxmlformats.org/presentationml/2006/main" xmlns:r="http://schemas.openxmlformats.org/officeDocument/2006/relationships">
+<p:sld xmlns:a="http://schemas.openxmlformats.org/drawingml/2006/main" xmlns:r="http://schemas.openxmlformats.org/officeDocument/2006/relationships" xmlns:p="http://schemas.openxmlformats.org/presentationml/2006/main">
   <p:cSld>
     <p:spTree>
       <p:nvGrpSpPr>
@@ -4183,7 +4242,14 @@
         <p:cNvGrpSpPr/>
         <p:nvPr/>
       </p:nvGrpSpPr>
-      <p:grpSpPr/>
+      <p:grpSpPr>
+        <a:xfrm>
+          <a:off x="0" y="0"/>
+          <a:ext cx="0" cy="0"/>
+          <a:chOff x="0" y="0"/>
+          <a:chExt cx="0" cy="0"/>
+        </a:xfrm>
+      </p:grpSpPr>
       <p:sp>
         <p:nvSpPr>
           <p:cNvPr id="2" name="Title 1"/>
@@ -4324,7 +4390,7 @@
 </file>
 
 <file path=ppt/slides/slide18.xml><?xml version="1.0" encoding="utf-8"?>
-<p:sld xmlns:a="http://schemas.openxmlformats.org/drawingml/2006/main" xmlns:p="http://schemas.openxmlformats.org/presentationml/2006/main" xmlns:r="http://schemas.openxmlformats.org/officeDocument/2006/relationships">
+<p:sld xmlns:a="http://schemas.openxmlformats.org/drawingml/2006/main" xmlns:r="http://schemas.openxmlformats.org/officeDocument/2006/relationships" xmlns:p="http://schemas.openxmlformats.org/presentationml/2006/main">
   <p:cSld>
     <p:spTree>
       <p:nvGrpSpPr>
@@ -4332,7 +4398,14 @@
         <p:cNvGrpSpPr/>
         <p:nvPr/>
       </p:nvGrpSpPr>
-      <p:grpSpPr/>
+      <p:grpSpPr>
+        <a:xfrm>
+          <a:off x="0" y="0"/>
+          <a:ext cx="0" cy="0"/>
+          <a:chOff x="0" y="0"/>
+          <a:chExt cx="0" cy="0"/>
+        </a:xfrm>
+      </p:grpSpPr>
       <p:sp>
         <p:nvSpPr>
           <p:cNvPr id="2" name="Title 1"/>
@@ -4473,7 +4546,7 @@
 </file>
 
 <file path=ppt/slides/slide19.xml><?xml version="1.0" encoding="utf-8"?>
-<p:sld xmlns:a="http://schemas.openxmlformats.org/drawingml/2006/main" xmlns:p="http://schemas.openxmlformats.org/presentationml/2006/main" xmlns:r="http://schemas.openxmlformats.org/officeDocument/2006/relationships">
+<p:sld xmlns:a="http://schemas.openxmlformats.org/drawingml/2006/main" xmlns:r="http://schemas.openxmlformats.org/officeDocument/2006/relationships" xmlns:p="http://schemas.openxmlformats.org/presentationml/2006/main">
   <p:cSld>
     <p:spTree>
       <p:nvGrpSpPr>
@@ -4481,7 +4554,14 @@
         <p:cNvGrpSpPr/>
         <p:nvPr/>
       </p:nvGrpSpPr>
-      <p:grpSpPr/>
+      <p:grpSpPr>
+        <a:xfrm>
+          <a:off x="0" y="0"/>
+          <a:ext cx="0" cy="0"/>
+          <a:chOff x="0" y="0"/>
+          <a:chExt cx="0" cy="0"/>
+        </a:xfrm>
+      </p:grpSpPr>
       <p:sp>
         <p:nvSpPr>
           <p:cNvPr id="2" name="Title 1"/>
@@ -4622,7 +4702,7 @@
 </file>
 
 <file path=ppt/slides/slide2.xml><?xml version="1.0" encoding="utf-8"?>
-<p:sld xmlns:a="http://schemas.openxmlformats.org/drawingml/2006/main" xmlns:p="http://schemas.openxmlformats.org/presentationml/2006/main" xmlns:r="http://schemas.openxmlformats.org/officeDocument/2006/relationships">
+<p:sld xmlns:a="http://schemas.openxmlformats.org/drawingml/2006/main" xmlns:r="http://schemas.openxmlformats.org/officeDocument/2006/relationships" xmlns:p="http://schemas.openxmlformats.org/presentationml/2006/main">
   <p:cSld>
     <p:spTree>
       <p:nvGrpSpPr>
@@ -4630,7 +4710,14 @@
         <p:cNvGrpSpPr/>
         <p:nvPr/>
       </p:nvGrpSpPr>
-      <p:grpSpPr/>
+      <p:grpSpPr>
+        <a:xfrm>
+          <a:off x="0" y="0"/>
+          <a:ext cx="0" cy="0"/>
+          <a:chOff x="0" y="0"/>
+          <a:chExt cx="0" cy="0"/>
+        </a:xfrm>
+      </p:grpSpPr>
       <p:sp>
         <p:nvSpPr>
           <p:cNvPr id="2" name="Title 1"/>
@@ -4664,28 +4751,33 @@
         </p:nvSpPr>
         <p:spPr/>
         <p:txBody>
-          <a:bodyPr/>
-          <a:lstStyle/>
-          <a:p>
-            <a:r>
+          <a:bodyPr>
+            <a:noAutofit/>
+          </a:bodyPr>
+          <a:lstStyle/>
+          <a:p>
+            <a:r>
+              <a:rPr sz="2800" dirty="0"/>
               <a:t>Abstract</a:t>
             </a:r>
           </a:p>
           <a:p>
             <a:pPr lvl="1"/>
             <a:r>
+              <a:rPr sz="2400" dirty="0"/>
               <a:t>Insurance AI Pro+ is an intelligent multi-domain insurance quotation system. It predicts insurance premiums and claim amounts using machine learning while providing Explainable AI (XAI) insights to users.</a:t>
             </a:r>
           </a:p>
           <a:p>
-            <a:pPr/>
-            <a:r>
+            <a:r>
+              <a:rPr sz="2800" dirty="0"/>
               <a:t>Introduction</a:t>
             </a:r>
           </a:p>
           <a:p>
             <a:pPr lvl="1"/>
             <a:r>
+              <a:rPr sz="2400" dirty="0"/>
               <a:t>Traditional actuarial models lack transparency for end-users. This project aims to bridge the gap by deploying dynamic, real-time prediction models across health, life, motor, property, business, specialty, and travel insurance.</a:t>
             </a:r>
           </a:p>
@@ -4700,7 +4792,7 @@
 </file>
 
 <file path=ppt/slides/slide20.xml><?xml version="1.0" encoding="utf-8"?>
-<p:sld xmlns:a="http://schemas.openxmlformats.org/drawingml/2006/main" xmlns:p="http://schemas.openxmlformats.org/presentationml/2006/main" xmlns:r="http://schemas.openxmlformats.org/officeDocument/2006/relationships">
+<p:sld xmlns:a="http://schemas.openxmlformats.org/drawingml/2006/main" xmlns:r="http://schemas.openxmlformats.org/officeDocument/2006/relationships" xmlns:p="http://schemas.openxmlformats.org/presentationml/2006/main">
   <p:cSld>
     <p:spTree>
       <p:nvGrpSpPr>
@@ -4708,7 +4800,14 @@
         <p:cNvGrpSpPr/>
         <p:nvPr/>
       </p:nvGrpSpPr>
-      <p:grpSpPr/>
+      <p:grpSpPr>
+        <a:xfrm>
+          <a:off x="0" y="0"/>
+          <a:ext cx="0" cy="0"/>
+          <a:chOff x="0" y="0"/>
+          <a:chExt cx="0" cy="0"/>
+        </a:xfrm>
+      </p:grpSpPr>
       <p:sp>
         <p:nvSpPr>
           <p:cNvPr id="2" name="Title 1"/>
@@ -4849,7 +4948,7 @@
 </file>
 
 <file path=ppt/slides/slide21.xml><?xml version="1.0" encoding="utf-8"?>
-<p:sld xmlns:a="http://schemas.openxmlformats.org/drawingml/2006/main" xmlns:p="http://schemas.openxmlformats.org/presentationml/2006/main" xmlns:r="http://schemas.openxmlformats.org/officeDocument/2006/relationships">
+<p:sld xmlns:a="http://schemas.openxmlformats.org/drawingml/2006/main" xmlns:r="http://schemas.openxmlformats.org/officeDocument/2006/relationships" xmlns:p="http://schemas.openxmlformats.org/presentationml/2006/main">
   <p:cSld>
     <p:spTree>
       <p:nvGrpSpPr>
@@ -4857,7 +4956,14 @@
         <p:cNvGrpSpPr/>
         <p:nvPr/>
       </p:nvGrpSpPr>
-      <p:grpSpPr/>
+      <p:grpSpPr>
+        <a:xfrm>
+          <a:off x="0" y="0"/>
+          <a:ext cx="0" cy="0"/>
+          <a:chOff x="0" y="0"/>
+          <a:chExt cx="0" cy="0"/>
+        </a:xfrm>
+      </p:grpSpPr>
       <p:sp>
         <p:nvSpPr>
           <p:cNvPr id="2" name="Title 1"/>
@@ -4998,7 +5104,7 @@
 </file>
 
 <file path=ppt/slides/slide22.xml><?xml version="1.0" encoding="utf-8"?>
-<p:sld xmlns:a="http://schemas.openxmlformats.org/drawingml/2006/main" xmlns:p="http://schemas.openxmlformats.org/presentationml/2006/main" xmlns:r="http://schemas.openxmlformats.org/officeDocument/2006/relationships">
+<p:sld xmlns:a="http://schemas.openxmlformats.org/drawingml/2006/main" xmlns:r="http://schemas.openxmlformats.org/officeDocument/2006/relationships" xmlns:p="http://schemas.openxmlformats.org/presentationml/2006/main">
   <p:cSld>
     <p:spTree>
       <p:nvGrpSpPr>
@@ -5006,7 +5112,14 @@
         <p:cNvGrpSpPr/>
         <p:nvPr/>
       </p:nvGrpSpPr>
-      <p:grpSpPr/>
+      <p:grpSpPr>
+        <a:xfrm>
+          <a:off x="0" y="0"/>
+          <a:ext cx="0" cy="0"/>
+          <a:chOff x="0" y="0"/>
+          <a:chExt cx="0" cy="0"/>
+        </a:xfrm>
+      </p:grpSpPr>
       <p:sp>
         <p:nvSpPr>
           <p:cNvPr id="2" name="Title 1"/>
@@ -5147,7 +5260,7 @@
 </file>
 
 <file path=ppt/slides/slide23.xml><?xml version="1.0" encoding="utf-8"?>
-<p:sld xmlns:a="http://schemas.openxmlformats.org/drawingml/2006/main" xmlns:p="http://schemas.openxmlformats.org/presentationml/2006/main" xmlns:r="http://schemas.openxmlformats.org/officeDocument/2006/relationships">
+<p:sld xmlns:a="http://schemas.openxmlformats.org/drawingml/2006/main" xmlns:r="http://schemas.openxmlformats.org/officeDocument/2006/relationships" xmlns:p="http://schemas.openxmlformats.org/presentationml/2006/main">
   <p:cSld>
     <p:spTree>
       <p:nvGrpSpPr>
@@ -5155,7 +5268,14 @@
         <p:cNvGrpSpPr/>
         <p:nvPr/>
       </p:nvGrpSpPr>
-      <p:grpSpPr/>
+      <p:grpSpPr>
+        <a:xfrm>
+          <a:off x="0" y="0"/>
+          <a:ext cx="0" cy="0"/>
+          <a:chOff x="0" y="0"/>
+          <a:chExt cx="0" cy="0"/>
+        </a:xfrm>
+      </p:grpSpPr>
       <p:sp>
         <p:nvSpPr>
           <p:cNvPr id="2" name="Title 1"/>
@@ -5296,7 +5416,7 @@
 </file>
 
 <file path=ppt/slides/slide24.xml><?xml version="1.0" encoding="utf-8"?>
-<p:sld xmlns:a="http://schemas.openxmlformats.org/drawingml/2006/main" xmlns:p="http://schemas.openxmlformats.org/presentationml/2006/main" xmlns:r="http://schemas.openxmlformats.org/officeDocument/2006/relationships">
+<p:sld xmlns:a="http://schemas.openxmlformats.org/drawingml/2006/main" xmlns:r="http://schemas.openxmlformats.org/officeDocument/2006/relationships" xmlns:p="http://schemas.openxmlformats.org/presentationml/2006/main">
   <p:cSld>
     <p:spTree>
       <p:nvGrpSpPr>
@@ -5304,7 +5424,14 @@
         <p:cNvGrpSpPr/>
         <p:nvPr/>
       </p:nvGrpSpPr>
-      <p:grpSpPr/>
+      <p:grpSpPr>
+        <a:xfrm>
+          <a:off x="0" y="0"/>
+          <a:ext cx="0" cy="0"/>
+          <a:chOff x="0" y="0"/>
+          <a:chExt cx="0" cy="0"/>
+        </a:xfrm>
+      </p:grpSpPr>
       <p:sp>
         <p:nvSpPr>
           <p:cNvPr id="2" name="Title 1"/>
@@ -5445,7 +5572,7 @@
 </file>
 
 <file path=ppt/slides/slide25.xml><?xml version="1.0" encoding="utf-8"?>
-<p:sld xmlns:a="http://schemas.openxmlformats.org/drawingml/2006/main" xmlns:p="http://schemas.openxmlformats.org/presentationml/2006/main" xmlns:r="http://schemas.openxmlformats.org/officeDocument/2006/relationships">
+<p:sld xmlns:a="http://schemas.openxmlformats.org/drawingml/2006/main" xmlns:r="http://schemas.openxmlformats.org/officeDocument/2006/relationships" xmlns:p="http://schemas.openxmlformats.org/presentationml/2006/main">
   <p:cSld>
     <p:spTree>
       <p:nvGrpSpPr>
@@ -5453,7 +5580,14 @@
         <p:cNvGrpSpPr/>
         <p:nvPr/>
       </p:nvGrpSpPr>
-      <p:grpSpPr/>
+      <p:grpSpPr>
+        <a:xfrm>
+          <a:off x="0" y="0"/>
+          <a:ext cx="0" cy="0"/>
+          <a:chOff x="0" y="0"/>
+          <a:chExt cx="0" cy="0"/>
+        </a:xfrm>
+      </p:grpSpPr>
       <p:sp>
         <p:nvSpPr>
           <p:cNvPr id="2" name="Title 1"/>
@@ -5594,7 +5728,7 @@
 </file>
 
 <file path=ppt/slides/slide26.xml><?xml version="1.0" encoding="utf-8"?>
-<p:sld xmlns:a="http://schemas.openxmlformats.org/drawingml/2006/main" xmlns:p="http://schemas.openxmlformats.org/presentationml/2006/main" xmlns:r="http://schemas.openxmlformats.org/officeDocument/2006/relationships">
+<p:sld xmlns:a="http://schemas.openxmlformats.org/drawingml/2006/main" xmlns:r="http://schemas.openxmlformats.org/officeDocument/2006/relationships" xmlns:p="http://schemas.openxmlformats.org/presentationml/2006/main">
   <p:cSld>
     <p:spTree>
       <p:nvGrpSpPr>
@@ -5602,7 +5736,14 @@
         <p:cNvGrpSpPr/>
         <p:nvPr/>
       </p:nvGrpSpPr>
-      <p:grpSpPr/>
+      <p:grpSpPr>
+        <a:xfrm>
+          <a:off x="0" y="0"/>
+          <a:ext cx="0" cy="0"/>
+          <a:chOff x="0" y="0"/>
+          <a:chExt cx="0" cy="0"/>
+        </a:xfrm>
+      </p:grpSpPr>
       <p:sp>
         <p:nvSpPr>
           <p:cNvPr id="2" name="Title 1"/>
@@ -5743,7 +5884,7 @@
 </file>
 
 <file path=ppt/slides/slide27.xml><?xml version="1.0" encoding="utf-8"?>
-<p:sld xmlns:a="http://schemas.openxmlformats.org/drawingml/2006/main" xmlns:p="http://schemas.openxmlformats.org/presentationml/2006/main" xmlns:r="http://schemas.openxmlformats.org/officeDocument/2006/relationships">
+<p:sld xmlns:a="http://schemas.openxmlformats.org/drawingml/2006/main" xmlns:r="http://schemas.openxmlformats.org/officeDocument/2006/relationships" xmlns:p="http://schemas.openxmlformats.org/presentationml/2006/main">
   <p:cSld>
     <p:spTree>
       <p:nvGrpSpPr>
@@ -5751,7 +5892,14 @@
         <p:cNvGrpSpPr/>
         <p:nvPr/>
       </p:nvGrpSpPr>
-      <p:grpSpPr/>
+      <p:grpSpPr>
+        <a:xfrm>
+          <a:off x="0" y="0"/>
+          <a:ext cx="0" cy="0"/>
+          <a:chOff x="0" y="0"/>
+          <a:chExt cx="0" cy="0"/>
+        </a:xfrm>
+      </p:grpSpPr>
       <p:sp>
         <p:nvSpPr>
           <p:cNvPr id="2" name="Title 1"/>
@@ -5892,7 +6040,7 @@
 </file>
 
 <file path=ppt/slides/slide28.xml><?xml version="1.0" encoding="utf-8"?>
-<p:sld xmlns:a="http://schemas.openxmlformats.org/drawingml/2006/main" xmlns:p="http://schemas.openxmlformats.org/presentationml/2006/main" xmlns:r="http://schemas.openxmlformats.org/officeDocument/2006/relationships">
+<p:sld xmlns:a="http://schemas.openxmlformats.org/drawingml/2006/main" xmlns:r="http://schemas.openxmlformats.org/officeDocument/2006/relationships" xmlns:p="http://schemas.openxmlformats.org/presentationml/2006/main">
   <p:cSld>
     <p:spTree>
       <p:nvGrpSpPr>
@@ -5900,7 +6048,14 @@
         <p:cNvGrpSpPr/>
         <p:nvPr/>
       </p:nvGrpSpPr>
-      <p:grpSpPr/>
+      <p:grpSpPr>
+        <a:xfrm>
+          <a:off x="0" y="0"/>
+          <a:ext cx="0" cy="0"/>
+          <a:chOff x="0" y="0"/>
+          <a:chExt cx="0" cy="0"/>
+        </a:xfrm>
+      </p:grpSpPr>
       <p:sp>
         <p:nvSpPr>
           <p:cNvPr id="2" name="Title 1"/>
@@ -6041,7 +6196,7 @@
 </file>
 
 <file path=ppt/slides/slide29.xml><?xml version="1.0" encoding="utf-8"?>
-<p:sld xmlns:a="http://schemas.openxmlformats.org/drawingml/2006/main" xmlns:p="http://schemas.openxmlformats.org/presentationml/2006/main" xmlns:r="http://schemas.openxmlformats.org/officeDocument/2006/relationships">
+<p:sld xmlns:a="http://schemas.openxmlformats.org/drawingml/2006/main" xmlns:r="http://schemas.openxmlformats.org/officeDocument/2006/relationships" xmlns:p="http://schemas.openxmlformats.org/presentationml/2006/main">
   <p:cSld>
     <p:spTree>
       <p:nvGrpSpPr>
@@ -6049,7 +6204,14 @@
         <p:cNvGrpSpPr/>
         <p:nvPr/>
       </p:nvGrpSpPr>
-      <p:grpSpPr/>
+      <p:grpSpPr>
+        <a:xfrm>
+          <a:off x="0" y="0"/>
+          <a:ext cx="0" cy="0"/>
+          <a:chOff x="0" y="0"/>
+          <a:chExt cx="0" cy="0"/>
+        </a:xfrm>
+      </p:grpSpPr>
       <p:sp>
         <p:nvSpPr>
           <p:cNvPr id="2" name="Title 1"/>
@@ -6190,7 +6352,7 @@
 </file>
 
 <file path=ppt/slides/slide3.xml><?xml version="1.0" encoding="utf-8"?>
-<p:sld xmlns:a="http://schemas.openxmlformats.org/drawingml/2006/main" xmlns:p="http://schemas.openxmlformats.org/presentationml/2006/main" xmlns:r="http://schemas.openxmlformats.org/officeDocument/2006/relationships">
+<p:sld xmlns:a="http://schemas.openxmlformats.org/drawingml/2006/main" xmlns:r="http://schemas.openxmlformats.org/officeDocument/2006/relationships" xmlns:p="http://schemas.openxmlformats.org/presentationml/2006/main">
   <p:cSld>
     <p:spTree>
       <p:nvGrpSpPr>
@@ -6198,7 +6360,14 @@
         <p:cNvGrpSpPr/>
         <p:nvPr/>
       </p:nvGrpSpPr>
-      <p:grpSpPr/>
+      <p:grpSpPr>
+        <a:xfrm>
+          <a:off x="0" y="0"/>
+          <a:ext cx="0" cy="0"/>
+          <a:chOff x="0" y="0"/>
+          <a:chExt cx="0" cy="0"/>
+        </a:xfrm>
+      </p:grpSpPr>
       <p:sp>
         <p:nvSpPr>
           <p:cNvPr id="2" name="Title 1"/>
@@ -6232,40 +6401,56 @@
         </p:nvSpPr>
         <p:spPr/>
         <p:txBody>
-          <a:bodyPr/>
-          <a:lstStyle/>
-          <a:p>
-            <a:r>
+          <a:bodyPr>
+            <a:noAutofit/>
+          </a:bodyPr>
+          <a:lstStyle/>
+          <a:p>
+            <a:r>
+              <a:rPr sz="2800" dirty="0"/>
               <a:t>Data Characteristics</a:t>
             </a:r>
           </a:p>
           <a:p>
             <a:pPr lvl="1"/>
             <a:r>
+              <a:rPr sz="2400" dirty="0"/>
               <a:t>Source: Custom statistical generation mirroring epidemiological/real-world distributions.</a:t>
             </a:r>
           </a:p>
           <a:p>
             <a:pPr lvl="1"/>
             <a:r>
+              <a:rPr sz="2400" dirty="0"/>
               <a:t>Records: Over 120,000 composite records.</a:t>
             </a:r>
           </a:p>
           <a:p>
             <a:pPr lvl="1"/>
             <a:r>
+              <a:rPr sz="2400" dirty="0"/>
               <a:t>Domains: Claim (50k rows), Health, Life, Motor, Business, Property, Travel, Specialty (each 10k rows).</a:t>
             </a:r>
           </a:p>
           <a:p>
             <a:pPr lvl="1"/>
             <a:r>
-              <a:t>Features: Core biological (Age, BMI, Blood Pressure), Categorical (Region, Smoker Status), Financial (Coverage Amount, No_Claim_Years).</a:t>
+              <a:rPr sz="2400" dirty="0"/>
+              <a:t>Features: Core biological (Age, BMI, Blood Pressure), Categorical (Region, Smoker Status), Financial (Coverage Amount, </a:t>
+            </a:r>
+            <a:r>
+              <a:rPr sz="2400" dirty="0" err="1"/>
+              <a:t>No_Claim_Years</a:t>
+            </a:r>
+            <a:r>
+              <a:rPr sz="2400" dirty="0"/>
+              <a:t>).</a:t>
             </a:r>
           </a:p>
           <a:p>
             <a:pPr lvl="1"/>
             <a:r>
+              <a:rPr sz="2400" dirty="0"/>
               <a:t>Target Variable: Premium / Claim Amount.</a:t>
             </a:r>
           </a:p>
@@ -6280,7 +6465,7 @@
 </file>
 
 <file path=ppt/slides/slide30.xml><?xml version="1.0" encoding="utf-8"?>
-<p:sld xmlns:a="http://schemas.openxmlformats.org/drawingml/2006/main" xmlns:p="http://schemas.openxmlformats.org/presentationml/2006/main" xmlns:r="http://schemas.openxmlformats.org/officeDocument/2006/relationships">
+<p:sld xmlns:a="http://schemas.openxmlformats.org/drawingml/2006/main" xmlns:r="http://schemas.openxmlformats.org/officeDocument/2006/relationships" xmlns:p="http://schemas.openxmlformats.org/presentationml/2006/main">
   <p:cSld>
     <p:spTree>
       <p:nvGrpSpPr>
@@ -6288,7 +6473,14 @@
         <p:cNvGrpSpPr/>
         <p:nvPr/>
       </p:nvGrpSpPr>
-      <p:grpSpPr/>
+      <p:grpSpPr>
+        <a:xfrm>
+          <a:off x="0" y="0"/>
+          <a:ext cx="0" cy="0"/>
+          <a:chOff x="0" y="0"/>
+          <a:chExt cx="0" cy="0"/>
+        </a:xfrm>
+      </p:grpSpPr>
       <p:sp>
         <p:nvSpPr>
           <p:cNvPr id="2" name="Title 1"/>
@@ -6429,7 +6621,7 @@
 </file>
 
 <file path=ppt/slides/slide31.xml><?xml version="1.0" encoding="utf-8"?>
-<p:sld xmlns:a="http://schemas.openxmlformats.org/drawingml/2006/main" xmlns:p="http://schemas.openxmlformats.org/presentationml/2006/main" xmlns:r="http://schemas.openxmlformats.org/officeDocument/2006/relationships">
+<p:sld xmlns:a="http://schemas.openxmlformats.org/drawingml/2006/main" xmlns:r="http://schemas.openxmlformats.org/officeDocument/2006/relationships" xmlns:p="http://schemas.openxmlformats.org/presentationml/2006/main">
   <p:cSld>
     <p:spTree>
       <p:nvGrpSpPr>
@@ -6437,7 +6629,14 @@
         <p:cNvGrpSpPr/>
         <p:nvPr/>
       </p:nvGrpSpPr>
-      <p:grpSpPr/>
+      <p:grpSpPr>
+        <a:xfrm>
+          <a:off x="0" y="0"/>
+          <a:ext cx="0" cy="0"/>
+          <a:chOff x="0" y="0"/>
+          <a:chExt cx="0" cy="0"/>
+        </a:xfrm>
+      </p:grpSpPr>
       <p:sp>
         <p:nvSpPr>
           <p:cNvPr id="2" name="Title 1"/>
@@ -6578,7 +6777,7 @@
 </file>
 
 <file path=ppt/slides/slide32.xml><?xml version="1.0" encoding="utf-8"?>
-<p:sld xmlns:a="http://schemas.openxmlformats.org/drawingml/2006/main" xmlns:p="http://schemas.openxmlformats.org/presentationml/2006/main" xmlns:r="http://schemas.openxmlformats.org/officeDocument/2006/relationships">
+<p:sld xmlns:a="http://schemas.openxmlformats.org/drawingml/2006/main" xmlns:r="http://schemas.openxmlformats.org/officeDocument/2006/relationships" xmlns:p="http://schemas.openxmlformats.org/presentationml/2006/main">
   <p:cSld>
     <p:spTree>
       <p:nvGrpSpPr>
@@ -6586,7 +6785,14 @@
         <p:cNvGrpSpPr/>
         <p:nvPr/>
       </p:nvGrpSpPr>
-      <p:grpSpPr/>
+      <p:grpSpPr>
+        <a:xfrm>
+          <a:off x="0" y="0"/>
+          <a:ext cx="0" cy="0"/>
+          <a:chOff x="0" y="0"/>
+          <a:chExt cx="0" cy="0"/>
+        </a:xfrm>
+      </p:grpSpPr>
       <p:sp>
         <p:nvSpPr>
           <p:cNvPr id="2" name="Title 1"/>
@@ -6727,7 +6933,7 @@
 </file>
 
 <file path=ppt/slides/slide33.xml><?xml version="1.0" encoding="utf-8"?>
-<p:sld xmlns:a="http://schemas.openxmlformats.org/drawingml/2006/main" xmlns:p="http://schemas.openxmlformats.org/presentationml/2006/main" xmlns:r="http://schemas.openxmlformats.org/officeDocument/2006/relationships">
+<p:sld xmlns:a="http://schemas.openxmlformats.org/drawingml/2006/main" xmlns:r="http://schemas.openxmlformats.org/officeDocument/2006/relationships" xmlns:p="http://schemas.openxmlformats.org/presentationml/2006/main">
   <p:cSld>
     <p:spTree>
       <p:nvGrpSpPr>
@@ -6735,7 +6941,14 @@
         <p:cNvGrpSpPr/>
         <p:nvPr/>
       </p:nvGrpSpPr>
-      <p:grpSpPr/>
+      <p:grpSpPr>
+        <a:xfrm>
+          <a:off x="0" y="0"/>
+          <a:ext cx="0" cy="0"/>
+          <a:chOff x="0" y="0"/>
+          <a:chExt cx="0" cy="0"/>
+        </a:xfrm>
+      </p:grpSpPr>
       <p:sp>
         <p:nvSpPr>
           <p:cNvPr id="2" name="Title 1"/>
@@ -6876,7 +7089,7 @@
 </file>
 
 <file path=ppt/slides/slide34.xml><?xml version="1.0" encoding="utf-8"?>
-<p:sld xmlns:a="http://schemas.openxmlformats.org/drawingml/2006/main" xmlns:p="http://schemas.openxmlformats.org/presentationml/2006/main" xmlns:r="http://schemas.openxmlformats.org/officeDocument/2006/relationships">
+<p:sld xmlns:a="http://schemas.openxmlformats.org/drawingml/2006/main" xmlns:r="http://schemas.openxmlformats.org/officeDocument/2006/relationships" xmlns:p="http://schemas.openxmlformats.org/presentationml/2006/main">
   <p:cSld>
     <p:spTree>
       <p:nvGrpSpPr>
@@ -6884,7 +7097,14 @@
         <p:cNvGrpSpPr/>
         <p:nvPr/>
       </p:nvGrpSpPr>
-      <p:grpSpPr/>
+      <p:grpSpPr>
+        <a:xfrm>
+          <a:off x="0" y="0"/>
+          <a:ext cx="0" cy="0"/>
+          <a:chOff x="0" y="0"/>
+          <a:chExt cx="0" cy="0"/>
+        </a:xfrm>
+      </p:grpSpPr>
       <p:sp>
         <p:nvSpPr>
           <p:cNvPr id="2" name="Title 1"/>
@@ -7025,7 +7245,7 @@
 </file>
 
 <file path=ppt/slides/slide35.xml><?xml version="1.0" encoding="utf-8"?>
-<p:sld xmlns:a="http://schemas.openxmlformats.org/drawingml/2006/main" xmlns:p="http://schemas.openxmlformats.org/presentationml/2006/main" xmlns:r="http://schemas.openxmlformats.org/officeDocument/2006/relationships">
+<p:sld xmlns:a="http://schemas.openxmlformats.org/drawingml/2006/main" xmlns:r="http://schemas.openxmlformats.org/officeDocument/2006/relationships" xmlns:p="http://schemas.openxmlformats.org/presentationml/2006/main">
   <p:cSld>
     <p:spTree>
       <p:nvGrpSpPr>
@@ -7033,7 +7253,14 @@
         <p:cNvGrpSpPr/>
         <p:nvPr/>
       </p:nvGrpSpPr>
-      <p:grpSpPr/>
+      <p:grpSpPr>
+        <a:xfrm>
+          <a:off x="0" y="0"/>
+          <a:ext cx="0" cy="0"/>
+          <a:chOff x="0" y="0"/>
+          <a:chExt cx="0" cy="0"/>
+        </a:xfrm>
+      </p:grpSpPr>
       <p:sp>
         <p:nvSpPr>
           <p:cNvPr id="2" name="Title 1"/>
@@ -7174,7 +7401,7 @@
 </file>
 
 <file path=ppt/slides/slide36.xml><?xml version="1.0" encoding="utf-8"?>
-<p:sld xmlns:a="http://schemas.openxmlformats.org/drawingml/2006/main" xmlns:p="http://schemas.openxmlformats.org/presentationml/2006/main" xmlns:r="http://schemas.openxmlformats.org/officeDocument/2006/relationships">
+<p:sld xmlns:a="http://schemas.openxmlformats.org/drawingml/2006/main" xmlns:r="http://schemas.openxmlformats.org/officeDocument/2006/relationships" xmlns:p="http://schemas.openxmlformats.org/presentationml/2006/main">
   <p:cSld>
     <p:spTree>
       <p:nvGrpSpPr>
@@ -7182,7 +7409,14 @@
         <p:cNvGrpSpPr/>
         <p:nvPr/>
       </p:nvGrpSpPr>
-      <p:grpSpPr/>
+      <p:grpSpPr>
+        <a:xfrm>
+          <a:off x="0" y="0"/>
+          <a:ext cx="0" cy="0"/>
+          <a:chOff x="0" y="0"/>
+          <a:chExt cx="0" cy="0"/>
+        </a:xfrm>
+      </p:grpSpPr>
       <p:sp>
         <p:nvSpPr>
           <p:cNvPr id="2" name="Title 1"/>
@@ -7323,7 +7557,7 @@
 </file>
 
 <file path=ppt/slides/slide37.xml><?xml version="1.0" encoding="utf-8"?>
-<p:sld xmlns:a="http://schemas.openxmlformats.org/drawingml/2006/main" xmlns:p="http://schemas.openxmlformats.org/presentationml/2006/main" xmlns:r="http://schemas.openxmlformats.org/officeDocument/2006/relationships">
+<p:sld xmlns:a="http://schemas.openxmlformats.org/drawingml/2006/main" xmlns:r="http://schemas.openxmlformats.org/officeDocument/2006/relationships" xmlns:p="http://schemas.openxmlformats.org/presentationml/2006/main">
   <p:cSld>
     <p:spTree>
       <p:nvGrpSpPr>
@@ -7331,7 +7565,14 @@
         <p:cNvGrpSpPr/>
         <p:nvPr/>
       </p:nvGrpSpPr>
-      <p:grpSpPr/>
+      <p:grpSpPr>
+        <a:xfrm>
+          <a:off x="0" y="0"/>
+          <a:ext cx="0" cy="0"/>
+          <a:chOff x="0" y="0"/>
+          <a:chExt cx="0" cy="0"/>
+        </a:xfrm>
+      </p:grpSpPr>
       <p:sp>
         <p:nvSpPr>
           <p:cNvPr id="2" name="Title 1"/>
@@ -7365,41 +7606,113 @@
         </p:nvSpPr>
         <p:spPr/>
         <p:txBody>
-          <a:bodyPr/>
-          <a:lstStyle/>
-          <a:p>
-            <a:r>
+          <a:bodyPr>
+            <a:noAutofit/>
+          </a:bodyPr>
+          <a:lstStyle/>
+          <a:p>
+            <a:r>
+              <a:rPr sz="2800" dirty="0"/>
               <a:t>Transformation Strategies</a:t>
             </a:r>
           </a:p>
           <a:p>
             <a:pPr lvl="1"/>
             <a:r>
-              <a:t>Missing Values: Median strategy for numericals (SimpleImputer) and Constant strategy ('Unknown') for categoricals.</a:t>
+              <a:rPr sz="2400" dirty="0"/>
+              <a:t>Missing Values: Median strategy for </a:t>
+            </a:r>
+            <a:r>
+              <a:rPr sz="2400" dirty="0" err="1"/>
+              <a:t>numericals</a:t>
+            </a:r>
+            <a:r>
+              <a:rPr sz="2400" dirty="0"/>
+              <a:t> (</a:t>
+            </a:r>
+            <a:r>
+              <a:rPr sz="2400" dirty="0" err="1"/>
+              <a:t>SimpleImputer</a:t>
+            </a:r>
+            <a:r>
+              <a:rPr sz="2400" dirty="0"/>
+              <a:t>) and Constant strategy ('Unknown') for </a:t>
+            </a:r>
+            <a:r>
+              <a:rPr sz="2400" dirty="0" err="1"/>
+              <a:t>categoricals</a:t>
+            </a:r>
+            <a:r>
+              <a:rPr sz="2400" dirty="0"/>
+              <a:t>.</a:t>
             </a:r>
           </a:p>
           <a:p>
             <a:pPr lvl="1"/>
             <a:r>
-              <a:t>Outliers: Variables mathematically capped via np.clip to prevent variance skew.</a:t>
+              <a:rPr sz="2400" dirty="0"/>
+              <a:t>Outliers: Variables mathematically capped via </a:t>
+            </a:r>
+            <a:r>
+              <a:rPr sz="2400" dirty="0" err="1"/>
+              <a:t>np.clip</a:t>
+            </a:r>
+            <a:r>
+              <a:rPr sz="2400" dirty="0"/>
+              <a:t> to prevent variance skew.</a:t>
             </a:r>
           </a:p>
           <a:p>
             <a:pPr lvl="1"/>
             <a:r>
-              <a:t>Scaling: Normalization via StandardScaler targeting optimal geometric space for distance algorithms (e.g. KNN/SVR).</a:t>
+              <a:rPr sz="2400" dirty="0"/>
+              <a:t>Scaling: Normalization via </a:t>
+            </a:r>
+            <a:r>
+              <a:rPr sz="2400" dirty="0" err="1"/>
+              <a:t>StandardScaler</a:t>
+            </a:r>
+            <a:r>
+              <a:rPr sz="2400" dirty="0"/>
+              <a:t> targeting optimal geometric space for distance algorithms (e.g. KNN/SVR).</a:t>
             </a:r>
           </a:p>
           <a:p>
             <a:pPr lvl="1"/>
             <a:r>
-              <a:t>Encoding: LabelEncoder (binary) &amp; OneHotEncoder for multi-class categorical configurations.</a:t>
+              <a:rPr sz="2400" dirty="0"/>
+              <a:t>Encoding: </a:t>
+            </a:r>
+            <a:r>
+              <a:rPr sz="2400" dirty="0" err="1"/>
+              <a:t>LabelEncoder</a:t>
+            </a:r>
+            <a:r>
+              <a:rPr sz="2400" dirty="0"/>
+              <a:t> (binary) &amp; </a:t>
+            </a:r>
+            <a:r>
+              <a:rPr sz="2400" dirty="0" err="1"/>
+              <a:t>OneHotEncoder</a:t>
+            </a:r>
+            <a:r>
+              <a:rPr sz="2400" dirty="0"/>
+              <a:t> for multi-class categorical configurations.</a:t>
             </a:r>
           </a:p>
           <a:p>
             <a:pPr lvl="1"/>
             <a:r>
-              <a:t>Feature Engineering: Synthesized variables via PolynomialFeatures (e.g. Compound actuarial risk of Age + Smoking).</a:t>
+              <a:rPr sz="2400" dirty="0"/>
+              <a:t>Feature Engineering: Synthesized variables via </a:t>
+            </a:r>
+            <a:r>
+              <a:rPr sz="2400" dirty="0" err="1"/>
+              <a:t>PolynomialFeatures</a:t>
+            </a:r>
+            <a:r>
+              <a:rPr sz="2400" dirty="0"/>
+              <a:t> (e.g. Compound actuarial risk of Age + Smoking).</a:t>
             </a:r>
           </a:p>
         </p:txBody>
@@ -7413,7 +7726,7 @@
 </file>
 
 <file path=ppt/slides/slide38.xml><?xml version="1.0" encoding="utf-8"?>
-<p:sld xmlns:a="http://schemas.openxmlformats.org/drawingml/2006/main" xmlns:p="http://schemas.openxmlformats.org/presentationml/2006/main" xmlns:r="http://schemas.openxmlformats.org/officeDocument/2006/relationships">
+<p:sld xmlns:a="http://schemas.openxmlformats.org/drawingml/2006/main" xmlns:r="http://schemas.openxmlformats.org/officeDocument/2006/relationships" xmlns:p="http://schemas.openxmlformats.org/presentationml/2006/main">
   <p:cSld>
     <p:spTree>
       <p:nvGrpSpPr>
@@ -7421,7 +7734,14 @@
         <p:cNvGrpSpPr/>
         <p:nvPr/>
       </p:nvGrpSpPr>
-      <p:grpSpPr/>
+      <p:grpSpPr>
+        <a:xfrm>
+          <a:off x="0" y="0"/>
+          <a:ext cx="0" cy="0"/>
+          <a:chOff x="0" y="0"/>
+          <a:chExt cx="0" cy="0"/>
+        </a:xfrm>
+      </p:grpSpPr>
       <p:sp>
         <p:nvSpPr>
           <p:cNvPr id="2" name="Title 1"/>
@@ -7455,52 +7775,69 @@
         </p:nvSpPr>
         <p:spPr/>
         <p:txBody>
-          <a:bodyPr/>
-          <a:lstStyle/>
-          <a:p>
-            <a:r>
+          <a:bodyPr>
+            <a:noAutofit/>
+          </a:bodyPr>
+          <a:lstStyle/>
+          <a:p>
+            <a:r>
+              <a:rPr sz="2800" dirty="0"/>
               <a:t>Machine Learning Evaluation Baseline:</a:t>
             </a:r>
           </a:p>
           <a:p>
             <a:pPr lvl="1"/>
             <a:r>
+              <a:rPr sz="2400" dirty="0"/>
               <a:t>Linear Algorithms: Linear Regression, SVR, KNN.</a:t>
             </a:r>
           </a:p>
           <a:p>
             <a:pPr lvl="1"/>
             <a:r>
+              <a:rPr sz="2400" dirty="0"/>
               <a:t>Tree Ensembles: Random Forest, Decision Tree.</a:t>
             </a:r>
           </a:p>
           <a:p>
             <a:pPr lvl="1"/>
             <a:r>
-              <a:t>Boosting Mechanisms: Gradient Boosting, XGBoost.</a:t>
-            </a:r>
-          </a:p>
-          <a:p>
-            <a:pPr/>
-            <a:r>
+              <a:rPr sz="2400" dirty="0"/>
+              <a:t>Boosting Mechanisms: Gradient Boosting, </a:t>
+            </a:r>
+            <a:r>
+              <a:rPr sz="2400" dirty="0" err="1"/>
+              <a:t>XGBoost</a:t>
+            </a:r>
+            <a:r>
+              <a:rPr sz="2400" dirty="0"/>
+              <a:t>.</a:t>
+            </a:r>
+          </a:p>
+          <a:p>
+            <a:r>
+              <a:rPr sz="2800" dirty="0"/>
               <a:t>Final Output Profiles:</a:t>
             </a:r>
           </a:p>
           <a:p>
             <a:pPr lvl="1"/>
             <a:r>
+              <a:rPr sz="2400" dirty="0"/>
               <a:t>Accuracy Benchmark: Maximum accepted Mean Absolute Error capped safely under ~$550 tolerance.</a:t>
             </a:r>
           </a:p>
           <a:p>
             <a:pPr lvl="1"/>
             <a:r>
+              <a:rPr sz="2400" dirty="0"/>
               <a:t>Best Method Found: Gradient Boosting mapped non-linear incentives successfully (R²: 0.9362 with MAE: $473).</a:t>
             </a:r>
           </a:p>
           <a:p>
             <a:pPr lvl="1"/>
             <a:r>
+              <a:rPr sz="2400" dirty="0"/>
               <a:t>Risk Profiler: Binary mapping users via Random Forest as High/Low risk yielded a highly resilient 99.71% test accuracy.</a:t>
             </a:r>
           </a:p>
@@ -7515,7 +7852,7 @@
 </file>
 
 <file path=ppt/slides/slide39.xml><?xml version="1.0" encoding="utf-8"?>
-<p:sld xmlns:a="http://schemas.openxmlformats.org/drawingml/2006/main" xmlns:p="http://schemas.openxmlformats.org/presentationml/2006/main" xmlns:r="http://schemas.openxmlformats.org/officeDocument/2006/relationships">
+<p:sld xmlns:a="http://schemas.openxmlformats.org/drawingml/2006/main" xmlns:r="http://schemas.openxmlformats.org/officeDocument/2006/relationships" xmlns:p="http://schemas.openxmlformats.org/presentationml/2006/main">
   <p:cSld>
     <p:spTree>
       <p:nvGrpSpPr>
@@ -7523,7 +7860,14 @@
         <p:cNvGrpSpPr/>
         <p:nvPr/>
       </p:nvGrpSpPr>
-      <p:grpSpPr/>
+      <p:grpSpPr>
+        <a:xfrm>
+          <a:off x="0" y="0"/>
+          <a:ext cx="0" cy="0"/>
+          <a:chOff x="0" y="0"/>
+          <a:chExt cx="0" cy="0"/>
+        </a:xfrm>
+      </p:grpSpPr>
       <p:sp>
         <p:nvSpPr>
           <p:cNvPr id="2" name="Title 1"/>
@@ -7557,64 +7901,83 @@
         </p:nvSpPr>
         <p:spPr/>
         <p:txBody>
-          <a:bodyPr/>
-          <a:lstStyle/>
-          <a:p>
-            <a:r>
-              <a:t>Model Performace (R² Score) Extrapolated Across Domains:</a:t>
+          <a:bodyPr>
+            <a:noAutofit/>
+          </a:bodyPr>
+          <a:lstStyle/>
+          <a:p>
+            <a:r>
+              <a:rPr sz="2400" dirty="0"/>
+              <a:t>Model </a:t>
+            </a:r>
+            <a:r>
+              <a:rPr sz="2400" dirty="0" err="1"/>
+              <a:t>Performace</a:t>
+            </a:r>
+            <a:r>
+              <a:rPr sz="2400" dirty="0"/>
+              <a:t> (R² Score) Extrapolated Across Domains:</a:t>
             </a:r>
           </a:p>
           <a:p>
             <a:pPr lvl="1"/>
             <a:r>
+              <a:rPr sz="2000" dirty="0"/>
               <a:t>Core Claim Dataset: Gradient Boosting successfully achieved 0.9362 R² ($473 MAE).</a:t>
             </a:r>
           </a:p>
           <a:p>
             <a:pPr lvl="1"/>
             <a:r>
+              <a:rPr sz="2000" dirty="0"/>
               <a:t>Travel Insurance: Top model yielded 0.7209 R².</a:t>
             </a:r>
           </a:p>
           <a:p>
             <a:pPr lvl="1"/>
             <a:r>
+              <a:rPr sz="2000" dirty="0"/>
               <a:t>Life Insurance: Top model yielded 0.6828 R².</a:t>
             </a:r>
           </a:p>
           <a:p>
             <a:pPr lvl="1"/>
             <a:r>
+              <a:rPr sz="2000" dirty="0"/>
               <a:t>Health Insurance: Top model yielded 0.6576 R².</a:t>
             </a:r>
           </a:p>
           <a:p>
             <a:pPr lvl="1"/>
             <a:r>
+              <a:rPr sz="2000" dirty="0"/>
               <a:t>Motor Insurance: Top model yielded 0.6301 R².</a:t>
             </a:r>
           </a:p>
           <a:p>
             <a:pPr lvl="1"/>
             <a:r>
+              <a:rPr sz="2000" dirty="0"/>
               <a:t>Property Insurance: Only dataset where Linear Regression prevailed (0.6253 R²).</a:t>
             </a:r>
           </a:p>
           <a:p>
             <a:pPr lvl="1"/>
             <a:r>
+              <a:rPr sz="2000" dirty="0"/>
               <a:t>Business Insurance: Top model yielded 0.5967 R².</a:t>
             </a:r>
           </a:p>
           <a:p>
             <a:pPr lvl="1"/>
             <a:r>
+              <a:rPr sz="2000" dirty="0"/>
               <a:t>Specialty Insurance: Top model yielded 0.5927 R².</a:t>
             </a:r>
           </a:p>
           <a:p>
-            <a:pPr/>
-            <a:r>
+            <a:r>
+              <a:rPr sz="2400" dirty="0"/>
               <a:t>Conclusion: Non-linear boosting models drastically outperform standardized distance formulas for insurance computation.</a:t>
             </a:r>
           </a:p>
@@ -7629,7 +7992,7 @@
 </file>
 
 <file path=ppt/slides/slide4.xml><?xml version="1.0" encoding="utf-8"?>
-<p:sld xmlns:a="http://schemas.openxmlformats.org/drawingml/2006/main" xmlns:p="http://schemas.openxmlformats.org/presentationml/2006/main" xmlns:r="http://schemas.openxmlformats.org/officeDocument/2006/relationships">
+<p:sld xmlns:a="http://schemas.openxmlformats.org/drawingml/2006/main" xmlns:r="http://schemas.openxmlformats.org/officeDocument/2006/relationships" xmlns:p="http://schemas.openxmlformats.org/presentationml/2006/main">
   <p:cSld>
     <p:spTree>
       <p:nvGrpSpPr>
@@ -7637,7 +8000,14 @@
         <p:cNvGrpSpPr/>
         <p:nvPr/>
       </p:nvGrpSpPr>
-      <p:grpSpPr/>
+      <p:grpSpPr>
+        <a:xfrm>
+          <a:off x="0" y="0"/>
+          <a:ext cx="0" cy="0"/>
+          <a:chOff x="0" y="0"/>
+          <a:chExt cx="0" cy="0"/>
+        </a:xfrm>
+      </p:grpSpPr>
       <p:sp>
         <p:nvSpPr>
           <p:cNvPr id="2" name="Title 1"/>
@@ -7778,7 +8148,7 @@
 </file>
 
 <file path=ppt/slides/slide5.xml><?xml version="1.0" encoding="utf-8"?>
-<p:sld xmlns:a="http://schemas.openxmlformats.org/drawingml/2006/main" xmlns:p="http://schemas.openxmlformats.org/presentationml/2006/main" xmlns:r="http://schemas.openxmlformats.org/officeDocument/2006/relationships">
+<p:sld xmlns:a="http://schemas.openxmlformats.org/drawingml/2006/main" xmlns:r="http://schemas.openxmlformats.org/officeDocument/2006/relationships" xmlns:p="http://schemas.openxmlformats.org/presentationml/2006/main">
   <p:cSld>
     <p:spTree>
       <p:nvGrpSpPr>
@@ -7786,7 +8156,14 @@
         <p:cNvGrpSpPr/>
         <p:nvPr/>
       </p:nvGrpSpPr>
-      <p:grpSpPr/>
+      <p:grpSpPr>
+        <a:xfrm>
+          <a:off x="0" y="0"/>
+          <a:ext cx="0" cy="0"/>
+          <a:chOff x="0" y="0"/>
+          <a:chExt cx="0" cy="0"/>
+        </a:xfrm>
+      </p:grpSpPr>
       <p:sp>
         <p:nvSpPr>
           <p:cNvPr id="2" name="Title 1"/>
@@ -7927,7 +8304,7 @@
 </file>
 
 <file path=ppt/slides/slide6.xml><?xml version="1.0" encoding="utf-8"?>
-<p:sld xmlns:a="http://schemas.openxmlformats.org/drawingml/2006/main" xmlns:p="http://schemas.openxmlformats.org/presentationml/2006/main" xmlns:r="http://schemas.openxmlformats.org/officeDocument/2006/relationships">
+<p:sld xmlns:a="http://schemas.openxmlformats.org/drawingml/2006/main" xmlns:r="http://schemas.openxmlformats.org/officeDocument/2006/relationships" xmlns:p="http://schemas.openxmlformats.org/presentationml/2006/main">
   <p:cSld>
     <p:spTree>
       <p:nvGrpSpPr>
@@ -7935,7 +8312,14 @@
         <p:cNvGrpSpPr/>
         <p:nvPr/>
       </p:nvGrpSpPr>
-      <p:grpSpPr/>
+      <p:grpSpPr>
+        <a:xfrm>
+          <a:off x="0" y="0"/>
+          <a:ext cx="0" cy="0"/>
+          <a:chOff x="0" y="0"/>
+          <a:chExt cx="0" cy="0"/>
+        </a:xfrm>
+      </p:grpSpPr>
       <p:sp>
         <p:nvSpPr>
           <p:cNvPr id="2" name="Title 1"/>
@@ -8076,7 +8460,7 @@
 </file>
 
 <file path=ppt/slides/slide7.xml><?xml version="1.0" encoding="utf-8"?>
-<p:sld xmlns:a="http://schemas.openxmlformats.org/drawingml/2006/main" xmlns:p="http://schemas.openxmlformats.org/presentationml/2006/main" xmlns:r="http://schemas.openxmlformats.org/officeDocument/2006/relationships">
+<p:sld xmlns:a="http://schemas.openxmlformats.org/drawingml/2006/main" xmlns:r="http://schemas.openxmlformats.org/officeDocument/2006/relationships" xmlns:p="http://schemas.openxmlformats.org/presentationml/2006/main">
   <p:cSld>
     <p:spTree>
       <p:nvGrpSpPr>
@@ -8084,7 +8468,14 @@
         <p:cNvGrpSpPr/>
         <p:nvPr/>
       </p:nvGrpSpPr>
-      <p:grpSpPr/>
+      <p:grpSpPr>
+        <a:xfrm>
+          <a:off x="0" y="0"/>
+          <a:ext cx="0" cy="0"/>
+          <a:chOff x="0" y="0"/>
+          <a:chExt cx="0" cy="0"/>
+        </a:xfrm>
+      </p:grpSpPr>
       <p:sp>
         <p:nvSpPr>
           <p:cNvPr id="2" name="Title 1"/>
@@ -8225,7 +8616,7 @@
 </file>
 
 <file path=ppt/slides/slide8.xml><?xml version="1.0" encoding="utf-8"?>
-<p:sld xmlns:a="http://schemas.openxmlformats.org/drawingml/2006/main" xmlns:p="http://schemas.openxmlformats.org/presentationml/2006/main" xmlns:r="http://schemas.openxmlformats.org/officeDocument/2006/relationships">
+<p:sld xmlns:a="http://schemas.openxmlformats.org/drawingml/2006/main" xmlns:r="http://schemas.openxmlformats.org/officeDocument/2006/relationships" xmlns:p="http://schemas.openxmlformats.org/presentationml/2006/main">
   <p:cSld>
     <p:spTree>
       <p:nvGrpSpPr>
@@ -8233,7 +8624,14 @@
         <p:cNvGrpSpPr/>
         <p:nvPr/>
       </p:nvGrpSpPr>
-      <p:grpSpPr/>
+      <p:grpSpPr>
+        <a:xfrm>
+          <a:off x="0" y="0"/>
+          <a:ext cx="0" cy="0"/>
+          <a:chOff x="0" y="0"/>
+          <a:chExt cx="0" cy="0"/>
+        </a:xfrm>
+      </p:grpSpPr>
       <p:sp>
         <p:nvSpPr>
           <p:cNvPr id="2" name="Title 1"/>
@@ -8374,7 +8772,7 @@
 </file>
 
 <file path=ppt/slides/slide9.xml><?xml version="1.0" encoding="utf-8"?>
-<p:sld xmlns:a="http://schemas.openxmlformats.org/drawingml/2006/main" xmlns:p="http://schemas.openxmlformats.org/presentationml/2006/main" xmlns:r="http://schemas.openxmlformats.org/officeDocument/2006/relationships">
+<p:sld xmlns:a="http://schemas.openxmlformats.org/drawingml/2006/main" xmlns:r="http://schemas.openxmlformats.org/officeDocument/2006/relationships" xmlns:p="http://schemas.openxmlformats.org/presentationml/2006/main">
   <p:cSld>
     <p:spTree>
       <p:nvGrpSpPr>
@@ -8382,7 +8780,14 @@
         <p:cNvGrpSpPr/>
         <p:nvPr/>
       </p:nvGrpSpPr>
-      <p:grpSpPr/>
+      <p:grpSpPr>
+        <a:xfrm>
+          <a:off x="0" y="0"/>
+          <a:ext cx="0" cy="0"/>
+          <a:chOff x="0" y="0"/>
+          <a:chExt cx="0" cy="0"/>
+        </a:xfrm>
+      </p:grpSpPr>
       <p:sp>
         <p:nvSpPr>
           <p:cNvPr id="2" name="Title 1"/>

</xml_diff>